<commit_message>
Updated the ppt and included a pdf version
</commit_message>
<xml_diff>
--- a/Slides/MiCM_IntroToR.pptx
+++ b/Slides/MiCM_IntroToR.pptx
@@ -2414,7 +2414,7 @@
           <a:p>
             <a:fld id="{217E5156-1B5D-054E-B5B2-E1B1BA160252}" type="datetimeFigureOut">
               <a:rPr lang="fr-FR" smtClean="0"/>
-              <a:t>04/02/2026</a:t>
+              <a:t>24/09/2026</a:t>
             </a:fld>
             <a:endParaRPr lang="fr-FR"/>
           </a:p>
@@ -11501,7 +11501,7 @@
                   <a:srgbClr val="69B0A0"/>
                 </a:solidFill>
               </a:rPr>
-              <a:t>Lead: Martina Yang</a:t>
+              <a:t>Lead: Thomas Zheng</a:t>
             </a:r>
             <a:br>
               <a:rPr lang="en-US" sz="3100" b="1" dirty="0">
@@ -11516,7 +11516,7 @@
                   <a:srgbClr val="69B0A0"/>
                 </a:solidFill>
               </a:rPr>
-              <a:t>Facilitator: Maria Haddad</a:t>
+              <a:t>Facilitator: Leighton Smith</a:t>
             </a:r>
             <a:br>
               <a:rPr lang="en-CA" sz="6600" dirty="0">
@@ -11537,7 +11537,7 @@
             </a:br>
             <a:r>
               <a:rPr lang="en-CA" sz="2200" dirty="0"/>
-              <a:t>Materials adapted from Adrien Osakwe,  Larisa M. Soto and Xiaoqi Xie.</a:t>
+              <a:t>Materials adapted from A. Osakwe, L. Soto, X. Xie, and M. Yang.</a:t>
             </a:r>
             <a:endParaRPr lang="en-US" sz="2200" dirty="0">
               <a:solidFill>
@@ -16393,10 +16393,10 @@
           <p:nvPr/>
         </p:nvPicPr>
         <p:blipFill>
-          <a:blip r:embed="rId2">
+          <a:blip>
             <a:extLst>
               <a:ext uri="{96DAC541-7B7A-43D3-8B79-37D633B846F1}">
-                <asvg:svgBlip xmlns:asvg="http://schemas.microsoft.com/office/drawing/2016/SVG/main" r:embed="rId3"/>
+                <asvg:svgBlip xmlns:asvg="http://schemas.microsoft.com/office/drawing/2016/SVG/main" r:embed="rId2"/>
               </a:ext>
             </a:extLst>
           </a:blip>
@@ -16634,10 +16634,10 @@
           <p:nvPr/>
         </p:nvPicPr>
         <p:blipFill>
-          <a:blip r:embed="rId2">
+          <a:blip>
             <a:extLst>
               <a:ext uri="{96DAC541-7B7A-43D3-8B79-37D633B846F1}">
-                <asvg:svgBlip xmlns:asvg="http://schemas.microsoft.com/office/drawing/2016/SVG/main" r:embed="rId3"/>
+                <asvg:svgBlip xmlns:asvg="http://schemas.microsoft.com/office/drawing/2016/SVG/main" r:embed="rId2"/>
               </a:ext>
             </a:extLst>
           </a:blip>
@@ -16734,10 +16734,10 @@
       </p:sp>
       <p:pic>
         <p:nvPicPr>
-          <p:cNvPr id="3" name="Picture 2">
+          <p:cNvPr id="4" name="Picture 3">
             <a:extLst>
               <a:ext uri="{FF2B5EF4-FFF2-40B4-BE49-F238E27FC236}">
-                <a16:creationId xmlns:a16="http://schemas.microsoft.com/office/drawing/2014/main" id="{0359B1E9-6D27-FD5C-E083-905F8955941E}"/>
+                <a16:creationId xmlns:a16="http://schemas.microsoft.com/office/drawing/2014/main" id="{385337E9-202E-B03D-3DB5-87F4D08B8070}"/>
               </a:ext>
             </a:extLst>
           </p:cNvPr>
@@ -16748,13 +16748,14 @@
         </p:nvPicPr>
         <p:blipFill>
           <a:blip r:embed="rId3"/>
-          <a:srcRect/>
-          <a:stretch/>
+          <a:stretch>
+            <a:fillRect/>
+          </a:stretch>
         </p:blipFill>
         <p:spPr>
           <a:xfrm>
-            <a:off x="745309" y="2169959"/>
-            <a:ext cx="7653382" cy="2518081"/>
+            <a:off x="916370" y="2007476"/>
+            <a:ext cx="7496205" cy="3021726"/>
           </a:xfrm>
           <a:prstGeom prst="rect">
             <a:avLst/>
@@ -17629,10 +17630,10 @@
           <p:nvPr/>
         </p:nvPicPr>
         <p:blipFill>
-          <a:blip r:embed="rId2">
+          <a:blip>
             <a:extLst>
               <a:ext uri="{96DAC541-7B7A-43D3-8B79-37D633B846F1}">
-                <asvg:svgBlip xmlns:asvg="http://schemas.microsoft.com/office/drawing/2016/SVG/main" r:embed="rId3"/>
+                <asvg:svgBlip xmlns:asvg="http://schemas.microsoft.com/office/drawing/2016/SVG/main" r:embed="rId2"/>
               </a:ext>
             </a:extLst>
           </a:blip>
@@ -18032,10 +18033,10 @@
           <p:nvPr/>
         </p:nvPicPr>
         <p:blipFill>
-          <a:blip r:embed="rId2">
+          <a:blip>
             <a:extLst>
               <a:ext uri="{96DAC541-7B7A-43D3-8B79-37D633B846F1}">
-                <asvg:svgBlip xmlns:asvg="http://schemas.microsoft.com/office/drawing/2016/SVG/main" r:embed="rId3"/>
+                <asvg:svgBlip xmlns:asvg="http://schemas.microsoft.com/office/drawing/2016/SVG/main" r:embed="rId2"/>
               </a:ext>
             </a:extLst>
           </a:blip>
@@ -20303,10 +20304,10 @@
           <p:nvPr/>
         </p:nvPicPr>
         <p:blipFill>
-          <a:blip r:embed="rId2">
+          <a:blip>
             <a:extLst>
               <a:ext uri="{96DAC541-7B7A-43D3-8B79-37D633B846F1}">
-                <asvg:svgBlip xmlns:asvg="http://schemas.microsoft.com/office/drawing/2016/SVG/main" r:embed="rId3"/>
+                <asvg:svgBlip xmlns:asvg="http://schemas.microsoft.com/office/drawing/2016/SVG/main" r:embed="rId2"/>
               </a:ext>
             </a:extLst>
           </a:blip>
@@ -20339,7 +20340,7 @@
           <p:nvPr/>
         </p:nvPicPr>
         <p:blipFill>
-          <a:blip r:embed="rId4">
+          <a:blip r:embed="rId3">
             <a:extLst>
               <a:ext uri="{28A0092B-C50C-407E-A947-70E740481C1C}">
                 <a14:useLocalDpi xmlns:a14="http://schemas.microsoft.com/office/drawing/2010/main" val="0"/>
@@ -20386,7 +20387,7 @@
           <p:nvPr/>
         </p:nvPicPr>
         <p:blipFill>
-          <a:blip r:embed="rId5"/>
+          <a:blip r:embed="rId4"/>
           <a:stretch>
             <a:fillRect/>
           </a:stretch>

</xml_diff>